<commit_message>
Add initial JAWS script for 3CX Windows Desktop App
</commit_message>
<xml_diff>
--- a/Praesentation_Barrierefreiheit.pptx
+++ b/Praesentation_Barrierefreiheit.pptx
@@ -224,7 +224,7 @@
           <a:p>
             <a:fld id="{7FFCB3C0-C4D2-4443-94B7-511EA8E27017}" type="datetimeFigureOut">
               <a:rPr lang="de-DE" smtClean="0"/>
-              <a:t>07.06.2026</a:t>
+              <a:t>08.06.2026</a:t>
             </a:fld>
             <a:endParaRPr lang="de-DE"/>
           </a:p>
@@ -537,7 +537,7 @@
           <a:p>
             <a:r>
               <a:rPr lang="de-DE" dirty="0"/>
-              <a:t>Mein Kollege Rainer Brell und ich möchten in den folgenden 5 Stunden, nein 20 Minuten, dafür sensibilisieren, wie man Software-Anwendungen prüfen, anpassen und barrierefrei entwickeln kann.</a:t>
+              <a:t>Mein Kollege Rainer Brell und ich möchten in den nächsten Minuten, dafür sensibilisieren, wie man Software-Anwendungen prüfen, anpassen und barrierefrei entwickeln kann.</a:t>
             </a:r>
           </a:p>
         </p:txBody>
@@ -624,7 +624,15 @@
           <a:p>
             <a:r>
               <a:rPr lang="de-DE" dirty="0"/>
-              <a:t>Vorab eine Warnung: Das wird jetzt aus Zeitgründen ein wilder Ritt durch die 3 Themengebiete – keine Angst, alle Infos, Codes und einiges mehr gibt es im Web unter der Adresse am Ende der Präsentation</a:t>
+              <a:t>Vorab eine Warnung: Das wird jetzt aus Zeitgründen </a:t>
+            </a:r>
+            <a:r>
+              <a:rPr lang="de-DE"/>
+              <a:t>ein etwas wilder </a:t>
+            </a:r>
+            <a:r>
+              <a:rPr lang="de-DE" dirty="0"/>
+              <a:t>Ritt durch die 3 Themengebiete – keine Angst, alle Infos, Codes und einiges mehr gibt es im Web unter der Adresse am Ende der Präsentation</a:t>
             </a:r>
           </a:p>
         </p:txBody>
@@ -1481,7 +1489,7 @@
           <a:p>
             <a:fld id="{5BCAD085-E8A6-8845-BD4E-CB4CCA059FC4}" type="datetimeFigureOut">
               <a:rPr lang="en-US" smtClean="0"/>
-              <a:t>6/7/2026</a:t>
+              <a:t>6/8/2026</a:t>
             </a:fld>
             <a:endParaRPr lang="en-US"/>
           </a:p>
@@ -1649,7 +1657,7 @@
           <a:p>
             <a:fld id="{5BCAD085-E8A6-8845-BD4E-CB4CCA059FC4}" type="datetimeFigureOut">
               <a:rPr lang="en-US" smtClean="0"/>
-              <a:t>6/7/2026</a:t>
+              <a:t>6/8/2026</a:t>
             </a:fld>
             <a:endParaRPr lang="en-US"/>
           </a:p>
@@ -1827,7 +1835,7 @@
           <a:p>
             <a:fld id="{5BCAD085-E8A6-8845-BD4E-CB4CCA059FC4}" type="datetimeFigureOut">
               <a:rPr lang="en-US" smtClean="0"/>
-              <a:t>6/7/2026</a:t>
+              <a:t>6/8/2026</a:t>
             </a:fld>
             <a:endParaRPr lang="en-US"/>
           </a:p>
@@ -1995,7 +2003,7 @@
           <a:p>
             <a:fld id="{5BCAD085-E8A6-8845-BD4E-CB4CCA059FC4}" type="datetimeFigureOut">
               <a:rPr lang="en-US" smtClean="0"/>
-              <a:t>6/7/2026</a:t>
+              <a:t>6/8/2026</a:t>
             </a:fld>
             <a:endParaRPr lang="en-US"/>
           </a:p>
@@ -2240,7 +2248,7 @@
           <a:p>
             <a:fld id="{5BCAD085-E8A6-8845-BD4E-CB4CCA059FC4}" type="datetimeFigureOut">
               <a:rPr lang="en-US" smtClean="0"/>
-              <a:t>6/7/2026</a:t>
+              <a:t>6/8/2026</a:t>
             </a:fld>
             <a:endParaRPr lang="en-US"/>
           </a:p>
@@ -2525,7 +2533,7 @@
           <a:p>
             <a:fld id="{5BCAD085-E8A6-8845-BD4E-CB4CCA059FC4}" type="datetimeFigureOut">
               <a:rPr lang="en-US" smtClean="0"/>
-              <a:t>6/7/2026</a:t>
+              <a:t>6/8/2026</a:t>
             </a:fld>
             <a:endParaRPr lang="en-US"/>
           </a:p>
@@ -2944,7 +2952,7 @@
           <a:p>
             <a:fld id="{5BCAD085-E8A6-8845-BD4E-CB4CCA059FC4}" type="datetimeFigureOut">
               <a:rPr lang="en-US" smtClean="0"/>
-              <a:t>6/7/2026</a:t>
+              <a:t>6/8/2026</a:t>
             </a:fld>
             <a:endParaRPr lang="en-US"/>
           </a:p>
@@ -3061,7 +3069,7 @@
           <a:p>
             <a:fld id="{5BCAD085-E8A6-8845-BD4E-CB4CCA059FC4}" type="datetimeFigureOut">
               <a:rPr lang="en-US" smtClean="0"/>
-              <a:t>6/7/2026</a:t>
+              <a:t>6/8/2026</a:t>
             </a:fld>
             <a:endParaRPr lang="en-US"/>
           </a:p>
@@ -3156,7 +3164,7 @@
           <a:p>
             <a:fld id="{5BCAD085-E8A6-8845-BD4E-CB4CCA059FC4}" type="datetimeFigureOut">
               <a:rPr lang="en-US" smtClean="0"/>
-              <a:t>6/7/2026</a:t>
+              <a:t>6/8/2026</a:t>
             </a:fld>
             <a:endParaRPr lang="en-US"/>
           </a:p>
@@ -3431,7 +3439,7 @@
           <a:p>
             <a:fld id="{5BCAD085-E8A6-8845-BD4E-CB4CCA059FC4}" type="datetimeFigureOut">
               <a:rPr lang="en-US" smtClean="0"/>
-              <a:t>6/7/2026</a:t>
+              <a:t>6/8/2026</a:t>
             </a:fld>
             <a:endParaRPr lang="en-US"/>
           </a:p>
@@ -3683,7 +3691,7 @@
           <a:p>
             <a:fld id="{5BCAD085-E8A6-8845-BD4E-CB4CCA059FC4}" type="datetimeFigureOut">
               <a:rPr lang="en-US" smtClean="0"/>
-              <a:t>6/7/2026</a:t>
+              <a:t>6/8/2026</a:t>
             </a:fld>
             <a:endParaRPr lang="en-US"/>
           </a:p>
@@ -3894,7 +3902,7 @@
           <a:p>
             <a:fld id="{5BCAD085-E8A6-8845-BD4E-CB4CCA059FC4}" type="datetimeFigureOut">
               <a:rPr lang="en-US" smtClean="0"/>
-              <a:t>6/7/2026</a:t>
+              <a:t>6/8/2026</a:t>
             </a:fld>
             <a:endParaRPr lang="en-US"/>
           </a:p>

</xml_diff>